<commit_message>
Update course annoucement materials
</commit_message>
<xml_diff>
--- a/advertisement/ad-scilifelab-digital-screens.pptx
+++ b/advertisement/ad-scilifelab-digital-screens.pptx
@@ -6,7 +6,6 @@
   </p:sldMasterIdLst>
   <p:sldIdLst>
     <p:sldId id="270" r:id="rId2"/>
-    <p:sldId id="269" r:id="rId3"/>
   </p:sldIdLst>
   <p:sldSz cx="12192000" cy="6858000"/>
   <p:notesSz cx="6858000" cy="9144000"/>
@@ -260,7 +259,7 @@
           <a:p>
             <a:fld id="{7588C33D-73BF-2E43-B53A-D686D9FCA367}" type="datetimeFigureOut">
               <a:rPr lang="en-US" smtClean="0"/>
-              <a:t>3/6/25</a:t>
+              <a:t>1/14/26</a:t>
             </a:fld>
             <a:endParaRPr lang="en-US" dirty="0"/>
           </a:p>
@@ -458,7 +457,7 @@
           <a:p>
             <a:fld id="{7588C33D-73BF-2E43-B53A-D686D9FCA367}" type="datetimeFigureOut">
               <a:rPr lang="en-US" smtClean="0"/>
-              <a:t>3/6/25</a:t>
+              <a:t>1/14/26</a:t>
             </a:fld>
             <a:endParaRPr lang="en-US" dirty="0"/>
           </a:p>
@@ -666,7 +665,7 @@
           <a:p>
             <a:fld id="{7588C33D-73BF-2E43-B53A-D686D9FCA367}" type="datetimeFigureOut">
               <a:rPr lang="en-US" smtClean="0"/>
-              <a:t>3/6/25</a:t>
+              <a:t>1/14/26</a:t>
             </a:fld>
             <a:endParaRPr lang="en-US" dirty="0"/>
           </a:p>
@@ -864,7 +863,7 @@
           <a:p>
             <a:fld id="{7588C33D-73BF-2E43-B53A-D686D9FCA367}" type="datetimeFigureOut">
               <a:rPr lang="en-US" smtClean="0"/>
-              <a:t>3/6/25</a:t>
+              <a:t>1/14/26</a:t>
             </a:fld>
             <a:endParaRPr lang="en-US" dirty="0"/>
           </a:p>
@@ -1139,7 +1138,7 @@
           <a:p>
             <a:fld id="{7588C33D-73BF-2E43-B53A-D686D9FCA367}" type="datetimeFigureOut">
               <a:rPr lang="en-US" smtClean="0"/>
-              <a:t>3/6/25</a:t>
+              <a:t>1/14/26</a:t>
             </a:fld>
             <a:endParaRPr lang="en-US" dirty="0"/>
           </a:p>
@@ -1404,7 +1403,7 @@
           <a:p>
             <a:fld id="{7588C33D-73BF-2E43-B53A-D686D9FCA367}" type="datetimeFigureOut">
               <a:rPr lang="en-US" smtClean="0"/>
-              <a:t>3/6/25</a:t>
+              <a:t>1/14/26</a:t>
             </a:fld>
             <a:endParaRPr lang="en-US" dirty="0"/>
           </a:p>
@@ -1816,7 +1815,7 @@
           <a:p>
             <a:fld id="{7588C33D-73BF-2E43-B53A-D686D9FCA367}" type="datetimeFigureOut">
               <a:rPr lang="en-US" smtClean="0"/>
-              <a:t>3/6/25</a:t>
+              <a:t>1/14/26</a:t>
             </a:fld>
             <a:endParaRPr lang="en-US" dirty="0"/>
           </a:p>
@@ -1957,7 +1956,7 @@
           <a:p>
             <a:fld id="{7588C33D-73BF-2E43-B53A-D686D9FCA367}" type="datetimeFigureOut">
               <a:rPr lang="en-US" smtClean="0"/>
-              <a:t>3/6/25</a:t>
+              <a:t>1/14/26</a:t>
             </a:fld>
             <a:endParaRPr lang="en-US" dirty="0"/>
           </a:p>
@@ -2070,7 +2069,7 @@
           <a:p>
             <a:fld id="{7588C33D-73BF-2E43-B53A-D686D9FCA367}" type="datetimeFigureOut">
               <a:rPr lang="en-US" smtClean="0"/>
-              <a:t>3/6/25</a:t>
+              <a:t>1/14/26</a:t>
             </a:fld>
             <a:endParaRPr lang="en-US" dirty="0"/>
           </a:p>
@@ -2381,7 +2380,7 @@
           <a:p>
             <a:fld id="{7588C33D-73BF-2E43-B53A-D686D9FCA367}" type="datetimeFigureOut">
               <a:rPr lang="en-US" smtClean="0"/>
-              <a:t>3/6/25</a:t>
+              <a:t>1/14/26</a:t>
             </a:fld>
             <a:endParaRPr lang="en-US" dirty="0"/>
           </a:p>
@@ -2669,7 +2668,7 @@
           <a:p>
             <a:fld id="{7588C33D-73BF-2E43-B53A-D686D9FCA367}" type="datetimeFigureOut">
               <a:rPr lang="en-US" smtClean="0"/>
-              <a:t>3/6/25</a:t>
+              <a:t>1/14/26</a:t>
             </a:fld>
             <a:endParaRPr lang="en-US" dirty="0"/>
           </a:p>
@@ -2910,7 +2909,7 @@
           <a:p>
             <a:fld id="{7588C33D-73BF-2E43-B53A-D686D9FCA367}" type="datetimeFigureOut">
               <a:rPr lang="en-US" smtClean="0"/>
-              <a:t>3/6/25</a:t>
+              <a:t>1/14/26</a:t>
             </a:fld>
             <a:endParaRPr lang="en-US" dirty="0"/>
           </a:p>
@@ -3461,7 +3460,7 @@
         <p:spPr>
           <a:xfrm>
             <a:off x="6540542" y="2942215"/>
-            <a:ext cx="4845542" cy="1600438"/>
+            <a:ext cx="4845542" cy="1815882"/>
           </a:xfrm>
           <a:prstGeom prst="rect">
             <a:avLst/>
@@ -3480,13 +3479,13 @@
                 <a:effectLst/>
                 <a:latin typeface="Helvetica Neue" panose="02000503000000020004" pitchFamily="2" charset="0"/>
               </a:rPr>
-              <a:t>National course for PhD students, researchers and other employees in need of biostatistical and machine learning skills. Probability theory. Hypothesis </a:t>
+              <a:t>National course for PhD students, researchers and other employees in need of biostatistical skills. Probability. Sampling and resampling. PCA and clustering. Hypothesis </a:t>
             </a:r>
             <a:r>
               <a:rPr lang="en-GB" sz="1400" dirty="0">
                 <a:latin typeface="Helvetica Neue" panose="02000503000000020004" pitchFamily="2" charset="0"/>
               </a:rPr>
-              <a:t>testing. Linear regression methods. GLM. Model evaluation. Clustering. Dimension reduction. Random Forest. </a:t>
+              <a:t>testing. Linear models. GLM. Mixed—effect models for repeated and hierarchical data. Survival analysis for time-to-event data.</a:t>
             </a:r>
           </a:p>
           <a:p>
@@ -3507,7 +3506,7 @@
               <a:rPr lang="en-GB" sz="1400" b="1" dirty="0">
                 <a:latin typeface="Helvetica Neue" panose="02000503000000020004" pitchFamily="2" charset="0"/>
               </a:rPr>
-              <a:t>March 14</a:t>
+              <a:t>January 30</a:t>
             </a:r>
             <a:r>
               <a:rPr lang="en-GB" sz="1400" b="1" baseline="30000" dirty="0">
@@ -3574,7 +3573,7 @@
               <a:rPr lang="en-US" sz="2600" b="1" dirty="0">
                 <a:latin typeface="Lato" panose="020F0502020204030203" pitchFamily="34" charset="77"/>
               </a:rPr>
-              <a:t>Introduction to Biostatistics and Machine Learning</a:t>
+              <a:t>Statistical Methods for Life Sciences</a:t>
             </a:r>
           </a:p>
         </p:txBody>
@@ -3834,13 +3833,22 @@
               </a:spcAft>
             </a:pPr>
             <a:r>
+              <a:rPr lang="sv-SE" sz="1800" b="1" dirty="0" err="1">
+                <a:solidFill>
+                  <a:schemeClr val="bg1"/>
+                </a:solidFill>
+                <a:latin typeface="Lato" panose="020F0502020204030203" pitchFamily="34" charset="77"/>
+              </a:rPr>
+              <a:t>March</a:t>
+            </a:r>
+            <a:r>
               <a:rPr lang="sv-SE" sz="1800" b="1" dirty="0">
                 <a:solidFill>
                   <a:schemeClr val="bg1"/>
                 </a:solidFill>
                 <a:latin typeface="Lato" panose="020F0502020204030203" pitchFamily="34" charset="77"/>
               </a:rPr>
-              <a:t>April 07</a:t>
+              <a:t> 09</a:t>
             </a:r>
             <a:r>
               <a:rPr lang="sv-SE" sz="1800" b="1" baseline="30000" dirty="0">
@@ -3858,7 +3866,7 @@
                 </a:solidFill>
                 <a:latin typeface="Lato" panose="020F0502020204030203" pitchFamily="34" charset="77"/>
               </a:rPr>
-              <a:t> – 11</a:t>
+              <a:t> – 13</a:t>
             </a:r>
             <a:r>
               <a:rPr lang="sv-SE" sz="1800" b="1" baseline="30000" dirty="0">
@@ -4227,10 +4235,10 @@
       </p:grpSp>
       <p:pic>
         <p:nvPicPr>
-          <p:cNvPr id="9" name="Picture 8">
-            <a:extLst>
-              <a:ext uri="{FF2B5EF4-FFF2-40B4-BE49-F238E27FC236}">
-                <a16:creationId xmlns:a16="http://schemas.microsoft.com/office/drawing/2014/main" id="{98411626-CFBD-8378-18AF-A8C76B65B510}"/>
+          <p:cNvPr id="18" name="Picture 17">
+            <a:extLst>
+              <a:ext uri="{FF2B5EF4-FFF2-40B4-BE49-F238E27FC236}">
+                <a16:creationId xmlns:a16="http://schemas.microsoft.com/office/drawing/2014/main" id="{CAEC8802-9B2C-45BE-8A5C-25EE761485C9}"/>
               </a:ext>
             </a:extLst>
           </p:cNvPr>
@@ -4247,8 +4255,8 @@
         </p:blipFill>
         <p:spPr>
           <a:xfrm>
-            <a:off x="10541056" y="5212903"/>
-            <a:ext cx="1078668" cy="1078668"/>
+            <a:off x="10308956" y="5024556"/>
+            <a:ext cx="1245675" cy="1229427"/>
           </a:xfrm>
           <a:prstGeom prst="rect">
             <a:avLst/>
@@ -4259,961 +4267,6 @@
     <p:extLst>
       <p:ext uri="{BB962C8B-B14F-4D97-AF65-F5344CB8AC3E}">
         <p14:creationId xmlns:p14="http://schemas.microsoft.com/office/powerpoint/2010/main" val="1052568210"/>
-      </p:ext>
-    </p:extLst>
-  </p:cSld>
-  <p:clrMapOvr>
-    <a:masterClrMapping/>
-  </p:clrMapOvr>
-</p:sld>
-</file>
-
-<file path=ppt/slides/slide2.xml><?xml version="1.0" encoding="utf-8"?>
-<p:sld xmlns:a="http://schemas.openxmlformats.org/drawingml/2006/main" xmlns:r="http://schemas.openxmlformats.org/officeDocument/2006/relationships" xmlns:p="http://schemas.openxmlformats.org/presentationml/2006/main">
-  <p:cSld>
-    <p:spTree>
-      <p:nvGrpSpPr>
-        <p:cNvPr id="1" name=""/>
-        <p:cNvGrpSpPr/>
-        <p:nvPr/>
-      </p:nvGrpSpPr>
-      <p:grpSpPr>
-        <a:xfrm>
-          <a:off x="0" y="0"/>
-          <a:ext cx="0" cy="0"/>
-          <a:chOff x="0" y="0"/>
-          <a:chExt cx="0" cy="0"/>
-        </a:xfrm>
-      </p:grpSpPr>
-      <p:pic>
-        <p:nvPicPr>
-          <p:cNvPr id="3" name="Picture 2">
-            <a:extLst>
-              <a:ext uri="{FF2B5EF4-FFF2-40B4-BE49-F238E27FC236}">
-                <a16:creationId xmlns:a16="http://schemas.microsoft.com/office/drawing/2014/main" id="{E13B2648-AFC7-BE6B-8769-74074A5A2122}"/>
-              </a:ext>
-            </a:extLst>
-          </p:cNvPr>
-          <p:cNvPicPr>
-            <a:picLocks noChangeAspect="1"/>
-          </p:cNvPicPr>
-          <p:nvPr/>
-        </p:nvPicPr>
-        <p:blipFill>
-          <a:blip r:embed="rId2"/>
-          <a:stretch>
-            <a:fillRect/>
-          </a:stretch>
-        </p:blipFill>
-        <p:spPr>
-          <a:xfrm>
-            <a:off x="10885" y="-13461"/>
-            <a:ext cx="12181115" cy="6884976"/>
-          </a:xfrm>
-          <a:prstGeom prst="rect">
-            <a:avLst/>
-          </a:prstGeom>
-        </p:spPr>
-      </p:pic>
-      <p:sp>
-        <p:nvSpPr>
-          <p:cNvPr id="4" name="Rectangle 3">
-            <a:extLst>
-              <a:ext uri="{FF2B5EF4-FFF2-40B4-BE49-F238E27FC236}">
-                <a16:creationId xmlns:a16="http://schemas.microsoft.com/office/drawing/2014/main" id="{93BA37B6-7DA7-A14A-B480-309586537846}"/>
-              </a:ext>
-            </a:extLst>
-          </p:cNvPr>
-          <p:cNvSpPr/>
-          <p:nvPr/>
-        </p:nvSpPr>
-        <p:spPr>
-          <a:xfrm>
-            <a:off x="6222925" y="559446"/>
-            <a:ext cx="5396798" cy="5754857"/>
-          </a:xfrm>
-          <a:prstGeom prst="rect">
-            <a:avLst/>
-          </a:prstGeom>
-          <a:solidFill>
-            <a:schemeClr val="bg1">
-              <a:alpha val="89385"/>
-            </a:schemeClr>
-          </a:solidFill>
-          <a:ln>
-            <a:noFill/>
-          </a:ln>
-        </p:spPr>
-        <p:style>
-          <a:lnRef idx="2">
-            <a:schemeClr val="dk1">
-              <a:shade val="50000"/>
-            </a:schemeClr>
-          </a:lnRef>
-          <a:fillRef idx="1">
-            <a:schemeClr val="dk1"/>
-          </a:fillRef>
-          <a:effectRef idx="0">
-            <a:schemeClr val="dk1"/>
-          </a:effectRef>
-          <a:fontRef idx="minor">
-            <a:schemeClr val="lt1"/>
-          </a:fontRef>
-        </p:style>
-        <p:txBody>
-          <a:bodyPr rtlCol="0" anchor="ctr"/>
-          <a:lstStyle/>
-          <a:p>
-            <a:pPr algn="ctr"/>
-            <a:endParaRPr lang="sv-SE" dirty="0">
-              <a:solidFill>
-                <a:srgbClr val="045C64"/>
-              </a:solidFill>
-            </a:endParaRPr>
-          </a:p>
-        </p:txBody>
-      </p:sp>
-      <p:sp>
-        <p:nvSpPr>
-          <p:cNvPr id="6" name="TextBox 5">
-            <a:extLst>
-              <a:ext uri="{FF2B5EF4-FFF2-40B4-BE49-F238E27FC236}">
-                <a16:creationId xmlns:a16="http://schemas.microsoft.com/office/drawing/2014/main" id="{6F713647-C2B5-1044-BCD0-B51981BC55A9}"/>
-              </a:ext>
-            </a:extLst>
-          </p:cNvPr>
-          <p:cNvSpPr txBox="1"/>
-          <p:nvPr/>
-        </p:nvSpPr>
-        <p:spPr>
-          <a:xfrm>
-            <a:off x="6533283" y="2950088"/>
-            <a:ext cx="4665569" cy="1600438"/>
-          </a:xfrm>
-          <a:prstGeom prst="rect">
-            <a:avLst/>
-          </a:prstGeom>
-          <a:noFill/>
-        </p:spPr>
-        <p:txBody>
-          <a:bodyPr wrap="square" rtlCol="0">
-            <a:spAutoFit/>
-          </a:bodyPr>
-          <a:lstStyle/>
-          <a:p>
-            <a:pPr algn="l"/>
-            <a:r>
-              <a:rPr lang="en-GB" sz="1400" dirty="0">
-                <a:effectLst/>
-                <a:latin typeface="Helvetica Neue" panose="02000503000000020004" pitchFamily="2" charset="0"/>
-              </a:rPr>
-              <a:t>National course for PhD students and researchers who </a:t>
-            </a:r>
-            <a:r>
-              <a:rPr lang="en-GB" sz="1400" dirty="0">
-                <a:latin typeface="Helvetica Neue" panose="02000503000000020004" pitchFamily="2" charset="0"/>
-              </a:rPr>
-              <a:t>want</a:t>
-            </a:r>
-            <a:r>
-              <a:rPr lang="en-GB" sz="1400" dirty="0">
-                <a:effectLst/>
-                <a:latin typeface="Helvetica Neue" panose="02000503000000020004" pitchFamily="2" charset="0"/>
-              </a:rPr>
-              <a:t> to improve their ability to </a:t>
-            </a:r>
-            <a:r>
-              <a:rPr lang="en-GB" sz="1400" dirty="0" err="1">
-                <a:effectLst/>
-                <a:latin typeface="Helvetica Neue" panose="02000503000000020004" pitchFamily="2" charset="0"/>
-              </a:rPr>
-              <a:t>analyze</a:t>
-            </a:r>
-            <a:r>
-              <a:rPr lang="en-GB" sz="1400" dirty="0">
-                <a:effectLst/>
-                <a:latin typeface="Helvetica Neue" panose="02000503000000020004" pitchFamily="2" charset="0"/>
-              </a:rPr>
-              <a:t> data. Expand </a:t>
-            </a:r>
-            <a:r>
-              <a:rPr lang="en-GB" sz="1400" dirty="0">
-                <a:latin typeface="Helvetica Neue" panose="02000503000000020004" pitchFamily="2" charset="0"/>
-              </a:rPr>
-              <a:t>your data skills with dimensionality reduction methods beyond PCA, mixed-effect models, survival, PLS for single and multi-omics data sets and neural networks. </a:t>
-            </a:r>
-          </a:p>
-          <a:p>
-            <a:pPr algn="l"/>
-            <a:endParaRPr lang="en-GB" sz="1400" dirty="0">
-              <a:effectLst/>
-              <a:latin typeface="Helvetica Neue" panose="02000503000000020004" pitchFamily="2" charset="0"/>
-            </a:endParaRPr>
-          </a:p>
-          <a:p>
-            <a:pPr algn="l"/>
-            <a:r>
-              <a:rPr lang="en-GB" sz="1400" dirty="0">
-                <a:latin typeface="Helvetica Neue" panose="02000503000000020004" pitchFamily="2" charset="0"/>
-              </a:rPr>
-              <a:t>Apply by </a:t>
-            </a:r>
-            <a:r>
-              <a:rPr lang="en-GB" sz="1400" b="1" dirty="0">
-                <a:latin typeface="Helvetica Neue" panose="02000503000000020004" pitchFamily="2" charset="0"/>
-              </a:rPr>
-              <a:t>May 2</a:t>
-            </a:r>
-            <a:r>
-              <a:rPr lang="en-GB" sz="1400" b="1" baseline="30000" dirty="0">
-                <a:latin typeface="Helvetica Neue" panose="02000503000000020004" pitchFamily="2" charset="0"/>
-              </a:rPr>
-              <a:t>nd</a:t>
-            </a:r>
-            <a:endParaRPr lang="en-GB" sz="1400" b="1" dirty="0">
-              <a:effectLst/>
-              <a:latin typeface="Helvetica Neue" panose="02000503000000020004" pitchFamily="2" charset="0"/>
-            </a:endParaRPr>
-          </a:p>
-        </p:txBody>
-      </p:sp>
-      <p:sp>
-        <p:nvSpPr>
-          <p:cNvPr id="7" name="Title 1">
-            <a:extLst>
-              <a:ext uri="{FF2B5EF4-FFF2-40B4-BE49-F238E27FC236}">
-                <a16:creationId xmlns:a16="http://schemas.microsoft.com/office/drawing/2014/main" id="{ABA4DF5A-3316-F04D-BB4D-899F4485CAC4}"/>
-              </a:ext>
-            </a:extLst>
-          </p:cNvPr>
-          <p:cNvSpPr txBox="1">
-            <a:spLocks/>
-          </p:cNvSpPr>
-          <p:nvPr/>
-        </p:nvSpPr>
-        <p:spPr>
-          <a:xfrm>
-            <a:off x="6523460" y="753455"/>
-            <a:ext cx="5022188" cy="905490"/>
-          </a:xfrm>
-          <a:prstGeom prst="rect">
-            <a:avLst/>
-          </a:prstGeom>
-        </p:spPr>
-        <p:txBody>
-          <a:bodyPr vert="horz" lIns="91440" tIns="45720" rIns="91440" bIns="45720" rtlCol="0" anchor="b">
-            <a:noAutofit/>
-          </a:bodyPr>
-          <a:lstStyle>
-            <a:lvl1pPr algn="ctr" defTabSz="914400" rtl="0" eaLnBrk="1" latinLnBrk="0" hangingPunct="1">
-              <a:lnSpc>
-                <a:spcPct val="90000"/>
-              </a:lnSpc>
-              <a:spcBef>
-                <a:spcPct val="0"/>
-              </a:spcBef>
-              <a:buNone/>
-              <a:defRPr sz="6000" kern="1200">
-                <a:solidFill>
-                  <a:schemeClr val="tx1"/>
-                </a:solidFill>
-                <a:latin typeface="+mj-lt"/>
-                <a:ea typeface="+mj-ea"/>
-                <a:cs typeface="+mj-cs"/>
-              </a:defRPr>
-            </a:lvl1pPr>
-          </a:lstStyle>
-          <a:p>
-            <a:pPr algn="l"/>
-            <a:r>
-              <a:rPr lang="en-US" sz="2600" b="1" dirty="0">
-                <a:latin typeface="Lato" panose="020F0502020204030203" pitchFamily="34" charset="77"/>
-              </a:rPr>
-              <a:t>Machine Learning in Life Sciences</a:t>
-            </a:r>
-          </a:p>
-        </p:txBody>
-      </p:sp>
-      <p:sp>
-        <p:nvSpPr>
-          <p:cNvPr id="16" name="Rectangle 15">
-            <a:extLst>
-              <a:ext uri="{FF2B5EF4-FFF2-40B4-BE49-F238E27FC236}">
-                <a16:creationId xmlns:a16="http://schemas.microsoft.com/office/drawing/2014/main" id="{7C0EC61C-1C8A-C041-8E21-1BA596EC5DBF}"/>
-              </a:ext>
-            </a:extLst>
-          </p:cNvPr>
-          <p:cNvSpPr/>
-          <p:nvPr/>
-        </p:nvSpPr>
-        <p:spPr>
-          <a:xfrm>
-            <a:off x="0" y="-13461"/>
-            <a:ext cx="2374199" cy="766916"/>
-          </a:xfrm>
-          <a:prstGeom prst="rect">
-            <a:avLst/>
-          </a:prstGeom>
-          <a:solidFill>
-            <a:srgbClr val="A7C947">
-              <a:alpha val="90000"/>
-            </a:srgbClr>
-          </a:solidFill>
-          <a:ln>
-            <a:noFill/>
-          </a:ln>
-        </p:spPr>
-        <p:style>
-          <a:lnRef idx="2">
-            <a:schemeClr val="dk1">
-              <a:shade val="50000"/>
-            </a:schemeClr>
-          </a:lnRef>
-          <a:fillRef idx="1">
-            <a:schemeClr val="dk1"/>
-          </a:fillRef>
-          <a:effectRef idx="0">
-            <a:schemeClr val="dk1"/>
-          </a:effectRef>
-          <a:fontRef idx="minor">
-            <a:schemeClr val="lt1"/>
-          </a:fontRef>
-        </p:style>
-        <p:txBody>
-          <a:bodyPr rtlCol="0" anchor="ctr"/>
-          <a:lstStyle/>
-          <a:p>
-            <a:pPr algn="ctr"/>
-            <a:endParaRPr lang="sv-SE" dirty="0">
-              <a:solidFill>
-                <a:srgbClr val="A7C947"/>
-              </a:solidFill>
-            </a:endParaRPr>
-          </a:p>
-        </p:txBody>
-      </p:sp>
-      <p:sp>
-        <p:nvSpPr>
-          <p:cNvPr id="17" name="Title 1">
-            <a:extLst>
-              <a:ext uri="{FF2B5EF4-FFF2-40B4-BE49-F238E27FC236}">
-                <a16:creationId xmlns:a16="http://schemas.microsoft.com/office/drawing/2014/main" id="{41014EED-7433-854A-B839-2BE1C25859B3}"/>
-              </a:ext>
-            </a:extLst>
-          </p:cNvPr>
-          <p:cNvSpPr txBox="1">
-            <a:spLocks/>
-          </p:cNvSpPr>
-          <p:nvPr/>
-        </p:nvSpPr>
-        <p:spPr>
-          <a:xfrm>
-            <a:off x="163387" y="152848"/>
-            <a:ext cx="1651685" cy="406598"/>
-          </a:xfrm>
-          <a:prstGeom prst="rect">
-            <a:avLst/>
-          </a:prstGeom>
-        </p:spPr>
-        <p:txBody>
-          <a:bodyPr vert="horz" lIns="91440" tIns="45720" rIns="91440" bIns="45720" rtlCol="0" anchor="b">
-            <a:noAutofit/>
-          </a:bodyPr>
-          <a:lstStyle>
-            <a:lvl1pPr algn="ctr" defTabSz="914400" rtl="0" eaLnBrk="1" latinLnBrk="0" hangingPunct="1">
-              <a:lnSpc>
-                <a:spcPct val="90000"/>
-              </a:lnSpc>
-              <a:spcBef>
-                <a:spcPct val="0"/>
-              </a:spcBef>
-              <a:buNone/>
-              <a:defRPr sz="6000" kern="1200">
-                <a:solidFill>
-                  <a:schemeClr val="tx1"/>
-                </a:solidFill>
-                <a:latin typeface="+mj-lt"/>
-                <a:ea typeface="+mj-ea"/>
-                <a:cs typeface="+mj-cs"/>
-              </a:defRPr>
-            </a:lvl1pPr>
-          </a:lstStyle>
-          <a:p>
-            <a:r>
-              <a:rPr lang="en-US" sz="2000" b="1" dirty="0">
-                <a:solidFill>
-                  <a:schemeClr val="bg1"/>
-                </a:solidFill>
-                <a:latin typeface="Lato" panose="020F0502020204030203" pitchFamily="34" charset="77"/>
-              </a:rPr>
-              <a:t>Course</a:t>
-            </a:r>
-          </a:p>
-        </p:txBody>
-      </p:sp>
-      <p:sp>
-        <p:nvSpPr>
-          <p:cNvPr id="23" name="Rectangle 22">
-            <a:extLst>
-              <a:ext uri="{FF2B5EF4-FFF2-40B4-BE49-F238E27FC236}">
-                <a16:creationId xmlns:a16="http://schemas.microsoft.com/office/drawing/2014/main" id="{61718965-13A5-AE43-82A1-C2DC68A41D9D}"/>
-              </a:ext>
-            </a:extLst>
-          </p:cNvPr>
-          <p:cNvSpPr/>
-          <p:nvPr/>
-        </p:nvSpPr>
-        <p:spPr>
-          <a:xfrm>
-            <a:off x="5888052" y="1914756"/>
-            <a:ext cx="3146502" cy="875814"/>
-          </a:xfrm>
-          <a:prstGeom prst="rect">
-            <a:avLst/>
-          </a:prstGeom>
-          <a:solidFill>
-            <a:srgbClr val="A7C947"/>
-          </a:solidFill>
-          <a:ln>
-            <a:noFill/>
-          </a:ln>
-        </p:spPr>
-        <p:style>
-          <a:lnRef idx="2">
-            <a:schemeClr val="accent1">
-              <a:shade val="50000"/>
-            </a:schemeClr>
-          </a:lnRef>
-          <a:fillRef idx="1">
-            <a:schemeClr val="accent1"/>
-          </a:fillRef>
-          <a:effectRef idx="0">
-            <a:schemeClr val="accent1"/>
-          </a:effectRef>
-          <a:fontRef idx="minor">
-            <a:schemeClr val="lt1"/>
-          </a:fontRef>
-        </p:style>
-        <p:txBody>
-          <a:bodyPr rtlCol="0" anchor="ctr"/>
-          <a:lstStyle/>
-          <a:p>
-            <a:pPr algn="ctr"/>
-            <a:endParaRPr lang="en-SE"/>
-          </a:p>
-        </p:txBody>
-      </p:sp>
-      <p:sp>
-        <p:nvSpPr>
-          <p:cNvPr id="25" name="Title 1">
-            <a:extLst>
-              <a:ext uri="{FF2B5EF4-FFF2-40B4-BE49-F238E27FC236}">
-                <a16:creationId xmlns:a16="http://schemas.microsoft.com/office/drawing/2014/main" id="{5634AFC7-DE1B-A54A-940F-E9AE8681AEDC}"/>
-              </a:ext>
-            </a:extLst>
-          </p:cNvPr>
-          <p:cNvSpPr txBox="1">
-            <a:spLocks/>
-          </p:cNvSpPr>
-          <p:nvPr/>
-        </p:nvSpPr>
-        <p:spPr>
-          <a:xfrm>
-            <a:off x="6008356" y="2104066"/>
-            <a:ext cx="5234659" cy="605608"/>
-          </a:xfrm>
-          <a:prstGeom prst="rect">
-            <a:avLst/>
-          </a:prstGeom>
-        </p:spPr>
-        <p:txBody>
-          <a:bodyPr vert="horz" lIns="91440" tIns="45720" rIns="91440" bIns="45720" rtlCol="0" anchor="b">
-            <a:noAutofit/>
-          </a:bodyPr>
-          <a:lstStyle>
-            <a:lvl1pPr algn="ctr" defTabSz="914400" rtl="0" eaLnBrk="1" latinLnBrk="0" hangingPunct="1">
-              <a:lnSpc>
-                <a:spcPct val="90000"/>
-              </a:lnSpc>
-              <a:spcBef>
-                <a:spcPct val="0"/>
-              </a:spcBef>
-              <a:buNone/>
-              <a:defRPr sz="6000" kern="1200">
-                <a:solidFill>
-                  <a:schemeClr val="tx1"/>
-                </a:solidFill>
-                <a:latin typeface="+mj-lt"/>
-                <a:ea typeface="+mj-ea"/>
-                <a:cs typeface="+mj-cs"/>
-              </a:defRPr>
-            </a:lvl1pPr>
-          </a:lstStyle>
-          <a:p>
-            <a:pPr algn="l">
-              <a:lnSpc>
-                <a:spcPct val="100000"/>
-              </a:lnSpc>
-              <a:spcAft>
-                <a:spcPts val="600"/>
-              </a:spcAft>
-            </a:pPr>
-            <a:r>
-              <a:rPr lang="sv-SE" sz="1800" b="1" dirty="0">
-                <a:solidFill>
-                  <a:schemeClr val="bg1"/>
-                </a:solidFill>
-                <a:latin typeface="Lato" panose="020F0502020204030203" pitchFamily="34" charset="77"/>
-              </a:rPr>
-              <a:t>June 09</a:t>
-            </a:r>
-            <a:r>
-              <a:rPr lang="sv-SE" sz="1800" b="1" baseline="30000" dirty="0">
-                <a:solidFill>
-                  <a:schemeClr val="bg1"/>
-                </a:solidFill>
-                <a:latin typeface="Lato" panose="020F0502020204030203" pitchFamily="34" charset="77"/>
-              </a:rPr>
-              <a:t>th</a:t>
-            </a:r>
-            <a:r>
-              <a:rPr lang="sv-SE" sz="1800" b="1" dirty="0">
-                <a:solidFill>
-                  <a:schemeClr val="bg1"/>
-                </a:solidFill>
-                <a:latin typeface="Lato" panose="020F0502020204030203" pitchFamily="34" charset="77"/>
-              </a:rPr>
-              <a:t> – 13</a:t>
-            </a:r>
-            <a:r>
-              <a:rPr lang="sv-SE" sz="1800" b="1" baseline="30000" dirty="0">
-                <a:solidFill>
-                  <a:schemeClr val="bg1"/>
-                </a:solidFill>
-                <a:latin typeface="Lato" panose="020F0502020204030203" pitchFamily="34" charset="77"/>
-              </a:rPr>
-              <a:t>th</a:t>
-            </a:r>
-          </a:p>
-          <a:p>
-            <a:pPr algn="l">
-              <a:lnSpc>
-                <a:spcPct val="100000"/>
-              </a:lnSpc>
-              <a:spcAft>
-                <a:spcPts val="600"/>
-              </a:spcAft>
-            </a:pPr>
-            <a:r>
-              <a:rPr lang="sv-SE" sz="1800" b="1" dirty="0">
-                <a:solidFill>
-                  <a:schemeClr val="bg1"/>
-                </a:solidFill>
-                <a:latin typeface="Lato" panose="020F0502020204030203" pitchFamily="34" charset="77"/>
-              </a:rPr>
-              <a:t>BMC, Uppsala</a:t>
-            </a:r>
-          </a:p>
-        </p:txBody>
-      </p:sp>
-      <p:grpSp>
-        <p:nvGrpSpPr>
-          <p:cNvPr id="9" name="Group 8">
-            <a:extLst>
-              <a:ext uri="{FF2B5EF4-FFF2-40B4-BE49-F238E27FC236}">
-                <a16:creationId xmlns:a16="http://schemas.microsoft.com/office/drawing/2014/main" id="{4B604044-2D67-014C-9BEC-79CE62C21DF5}"/>
-              </a:ext>
-            </a:extLst>
-          </p:cNvPr>
-          <p:cNvGrpSpPr/>
-          <p:nvPr/>
-        </p:nvGrpSpPr>
-        <p:grpSpPr>
-          <a:xfrm>
-            <a:off x="6511511" y="4719602"/>
-            <a:ext cx="4958316" cy="1489441"/>
-            <a:chOff x="6538573" y="4441922"/>
-            <a:chExt cx="4869555" cy="1006730"/>
-          </a:xfrm>
-        </p:grpSpPr>
-        <p:sp>
-          <p:nvSpPr>
-            <p:cNvPr id="18" name="Subtitle 2">
-              <a:extLst>
-                <a:ext uri="{FF2B5EF4-FFF2-40B4-BE49-F238E27FC236}">
-                  <a16:creationId xmlns:a16="http://schemas.microsoft.com/office/drawing/2014/main" id="{D8ADE09B-10F1-1E4C-A772-A31E75B12736}"/>
-                </a:ext>
-              </a:extLst>
-            </p:cNvPr>
-            <p:cNvSpPr txBox="1">
-              <a:spLocks/>
-            </p:cNvSpPr>
-            <p:nvPr/>
-          </p:nvSpPr>
-          <p:spPr>
-            <a:xfrm>
-              <a:off x="6562586" y="4441922"/>
-              <a:ext cx="4845542" cy="663643"/>
-            </a:xfrm>
-            <a:prstGeom prst="rect">
-              <a:avLst/>
-            </a:prstGeom>
-          </p:spPr>
-          <p:txBody>
-            <a:bodyPr>
-              <a:noAutofit/>
-            </a:bodyPr>
-            <a:lstStyle>
-              <a:lvl1pPr marL="228600" indent="-228600" algn="l" defTabSz="914400" rtl="0" eaLnBrk="1" latinLnBrk="0" hangingPunct="1">
-                <a:lnSpc>
-                  <a:spcPct val="90000"/>
-                </a:lnSpc>
-                <a:spcBef>
-                  <a:spcPts val="1000"/>
-                </a:spcBef>
-                <a:buFont typeface="Arial" panose="020B0604020202020204" pitchFamily="34" charset="0"/>
-                <a:buChar char="•"/>
-                <a:defRPr sz="2800" kern="1200">
-                  <a:solidFill>
-                    <a:schemeClr val="tx1"/>
-                  </a:solidFill>
-                  <a:latin typeface="+mn-lt"/>
-                  <a:ea typeface="+mn-ea"/>
-                  <a:cs typeface="+mn-cs"/>
-                </a:defRPr>
-              </a:lvl1pPr>
-              <a:lvl2pPr marL="685800" indent="-228600" algn="l" defTabSz="914400" rtl="0" eaLnBrk="1" latinLnBrk="0" hangingPunct="1">
-                <a:lnSpc>
-                  <a:spcPct val="90000"/>
-                </a:lnSpc>
-                <a:spcBef>
-                  <a:spcPts val="500"/>
-                </a:spcBef>
-                <a:buFont typeface="Arial" panose="020B0604020202020204" pitchFamily="34" charset="0"/>
-                <a:buChar char="•"/>
-                <a:defRPr sz="2400" kern="1200">
-                  <a:solidFill>
-                    <a:schemeClr val="tx1"/>
-                  </a:solidFill>
-                  <a:latin typeface="+mn-lt"/>
-                  <a:ea typeface="+mn-ea"/>
-                  <a:cs typeface="+mn-cs"/>
-                </a:defRPr>
-              </a:lvl2pPr>
-              <a:lvl3pPr marL="1143000" indent="-228600" algn="l" defTabSz="914400" rtl="0" eaLnBrk="1" latinLnBrk="0" hangingPunct="1">
-                <a:lnSpc>
-                  <a:spcPct val="90000"/>
-                </a:lnSpc>
-                <a:spcBef>
-                  <a:spcPts val="500"/>
-                </a:spcBef>
-                <a:buFont typeface="Arial" panose="020B0604020202020204" pitchFamily="34" charset="0"/>
-                <a:buChar char="•"/>
-                <a:defRPr sz="2000" kern="1200">
-                  <a:solidFill>
-                    <a:schemeClr val="tx1"/>
-                  </a:solidFill>
-                  <a:latin typeface="+mn-lt"/>
-                  <a:ea typeface="+mn-ea"/>
-                  <a:cs typeface="+mn-cs"/>
-                </a:defRPr>
-              </a:lvl3pPr>
-              <a:lvl4pPr marL="1600200" indent="-228600" algn="l" defTabSz="914400" rtl="0" eaLnBrk="1" latinLnBrk="0" hangingPunct="1">
-                <a:lnSpc>
-                  <a:spcPct val="90000"/>
-                </a:lnSpc>
-                <a:spcBef>
-                  <a:spcPts val="500"/>
-                </a:spcBef>
-                <a:buFont typeface="Arial" panose="020B0604020202020204" pitchFamily="34" charset="0"/>
-                <a:buChar char="•"/>
-                <a:defRPr sz="1800" kern="1200">
-                  <a:solidFill>
-                    <a:schemeClr val="tx1"/>
-                  </a:solidFill>
-                  <a:latin typeface="+mn-lt"/>
-                  <a:ea typeface="+mn-ea"/>
-                  <a:cs typeface="+mn-cs"/>
-                </a:defRPr>
-              </a:lvl4pPr>
-              <a:lvl5pPr marL="2057400" indent="-228600" algn="l" defTabSz="914400" rtl="0" eaLnBrk="1" latinLnBrk="0" hangingPunct="1">
-                <a:lnSpc>
-                  <a:spcPct val="90000"/>
-                </a:lnSpc>
-                <a:spcBef>
-                  <a:spcPts val="500"/>
-                </a:spcBef>
-                <a:buFont typeface="Arial" panose="020B0604020202020204" pitchFamily="34" charset="0"/>
-                <a:buChar char="•"/>
-                <a:defRPr sz="1800" kern="1200">
-                  <a:solidFill>
-                    <a:schemeClr val="tx1"/>
-                  </a:solidFill>
-                  <a:latin typeface="+mn-lt"/>
-                  <a:ea typeface="+mn-ea"/>
-                  <a:cs typeface="+mn-cs"/>
-                </a:defRPr>
-              </a:lvl5pPr>
-              <a:lvl6pPr marL="2514600" indent="-228600" algn="l" defTabSz="914400" rtl="0" eaLnBrk="1" latinLnBrk="0" hangingPunct="1">
-                <a:lnSpc>
-                  <a:spcPct val="90000"/>
-                </a:lnSpc>
-                <a:spcBef>
-                  <a:spcPts val="500"/>
-                </a:spcBef>
-                <a:buFont typeface="Arial" panose="020B0604020202020204" pitchFamily="34" charset="0"/>
-                <a:buChar char="•"/>
-                <a:defRPr sz="1800" kern="1200">
-                  <a:solidFill>
-                    <a:schemeClr val="tx1"/>
-                  </a:solidFill>
-                  <a:latin typeface="+mn-lt"/>
-                  <a:ea typeface="+mn-ea"/>
-                  <a:cs typeface="+mn-cs"/>
-                </a:defRPr>
-              </a:lvl6pPr>
-              <a:lvl7pPr marL="2971800" indent="-228600" algn="l" defTabSz="914400" rtl="0" eaLnBrk="1" latinLnBrk="0" hangingPunct="1">
-                <a:lnSpc>
-                  <a:spcPct val="90000"/>
-                </a:lnSpc>
-                <a:spcBef>
-                  <a:spcPts val="500"/>
-                </a:spcBef>
-                <a:buFont typeface="Arial" panose="020B0604020202020204" pitchFamily="34" charset="0"/>
-                <a:buChar char="•"/>
-                <a:defRPr sz="1800" kern="1200">
-                  <a:solidFill>
-                    <a:schemeClr val="tx1"/>
-                  </a:solidFill>
-                  <a:latin typeface="+mn-lt"/>
-                  <a:ea typeface="+mn-ea"/>
-                  <a:cs typeface="+mn-cs"/>
-                </a:defRPr>
-              </a:lvl7pPr>
-              <a:lvl8pPr marL="3429000" indent="-228600" algn="l" defTabSz="914400" rtl="0" eaLnBrk="1" latinLnBrk="0" hangingPunct="1">
-                <a:lnSpc>
-                  <a:spcPct val="90000"/>
-                </a:lnSpc>
-                <a:spcBef>
-                  <a:spcPts val="500"/>
-                </a:spcBef>
-                <a:buFont typeface="Arial" panose="020B0604020202020204" pitchFamily="34" charset="0"/>
-                <a:buChar char="•"/>
-                <a:defRPr sz="1800" kern="1200">
-                  <a:solidFill>
-                    <a:schemeClr val="tx1"/>
-                  </a:solidFill>
-                  <a:latin typeface="+mn-lt"/>
-                  <a:ea typeface="+mn-ea"/>
-                  <a:cs typeface="+mn-cs"/>
-                </a:defRPr>
-              </a:lvl8pPr>
-              <a:lvl9pPr marL="3886200" indent="-228600" algn="l" defTabSz="914400" rtl="0" eaLnBrk="1" latinLnBrk="0" hangingPunct="1">
-                <a:lnSpc>
-                  <a:spcPct val="90000"/>
-                </a:lnSpc>
-                <a:spcBef>
-                  <a:spcPts val="500"/>
-                </a:spcBef>
-                <a:buFont typeface="Arial" panose="020B0604020202020204" pitchFamily="34" charset="0"/>
-                <a:buChar char="•"/>
-                <a:defRPr sz="1800" kern="1200">
-                  <a:solidFill>
-                    <a:schemeClr val="tx1"/>
-                  </a:solidFill>
-                  <a:latin typeface="+mn-lt"/>
-                  <a:ea typeface="+mn-ea"/>
-                  <a:cs typeface="+mn-cs"/>
-                </a:defRPr>
-              </a:lvl9pPr>
-            </a:lstStyle>
-            <a:p>
-              <a:pPr marL="0" indent="0">
-                <a:lnSpc>
-                  <a:spcPct val="100000"/>
-                </a:lnSpc>
-                <a:spcBef>
-                  <a:spcPts val="0"/>
-                </a:spcBef>
-                <a:spcAft>
-                  <a:spcPts val="600"/>
-                </a:spcAft>
-                <a:buNone/>
-              </a:pPr>
-              <a:r>
-                <a:rPr lang="en-US" sz="1600" dirty="0">
-                  <a:latin typeface="Lato" panose="020F0502020204030203" pitchFamily="34" charset="77"/>
-                </a:rPr>
-                <a:t>Read more: </a:t>
-              </a:r>
-            </a:p>
-            <a:p>
-              <a:pPr marL="0" indent="0">
-                <a:lnSpc>
-                  <a:spcPct val="100000"/>
-                </a:lnSpc>
-                <a:spcBef>
-                  <a:spcPts val="0"/>
-                </a:spcBef>
-                <a:spcAft>
-                  <a:spcPts val="600"/>
-                </a:spcAft>
-                <a:buNone/>
-              </a:pPr>
-              <a:r>
-                <a:rPr lang="en-US" sz="1600" b="1" i="1" dirty="0">
-                  <a:latin typeface="Lato" panose="020F0502020204030203" pitchFamily="34" charset="77"/>
-                </a:rPr>
-                <a:t>https://</a:t>
-              </a:r>
-              <a:r>
-                <a:rPr lang="en-US" sz="1600" b="1" i="1" dirty="0" err="1">
-                  <a:latin typeface="Lato" panose="020F0502020204030203" pitchFamily="34" charset="77"/>
-                </a:rPr>
-                <a:t>nbisweden.github.io</a:t>
-              </a:r>
-              <a:r>
-                <a:rPr lang="en-US" sz="1600" b="1" i="1" dirty="0">
-                  <a:latin typeface="Lato" panose="020F0502020204030203" pitchFamily="34" charset="77"/>
-                </a:rPr>
-                <a:t>/ML4Life/</a:t>
-              </a:r>
-            </a:p>
-            <a:p>
-              <a:pPr marL="0" indent="0">
-                <a:lnSpc>
-                  <a:spcPct val="100000"/>
-                </a:lnSpc>
-                <a:spcBef>
-                  <a:spcPts val="0"/>
-                </a:spcBef>
-                <a:spcAft>
-                  <a:spcPts val="600"/>
-                </a:spcAft>
-                <a:buNone/>
-              </a:pPr>
-              <a:r>
-                <a:rPr lang="en-US" sz="1600" dirty="0">
-                  <a:latin typeface="Lato" panose="020F0502020204030203" pitchFamily="34" charset="77"/>
-                </a:rPr>
-                <a:t>or </a:t>
-              </a:r>
-              <a:r>
-                <a:rPr lang="en-US" sz="1600" b="1" i="1" dirty="0">
-                  <a:latin typeface="Lato" panose="020F0502020204030203" pitchFamily="34" charset="77"/>
-                </a:rPr>
-                <a:t>https://</a:t>
-              </a:r>
-              <a:r>
-                <a:rPr lang="en-US" sz="1600" b="1" i="1" dirty="0" err="1">
-                  <a:latin typeface="Lato" panose="020F0502020204030203" pitchFamily="34" charset="77"/>
-                </a:rPr>
-                <a:t>training.scilifelab.se</a:t>
-              </a:r>
-              <a:r>
-                <a:rPr lang="en-US" sz="1600" b="1" i="1" dirty="0">
-                  <a:latin typeface="Lato" panose="020F0502020204030203" pitchFamily="34" charset="77"/>
-                </a:rPr>
-                <a:t>/events</a:t>
-              </a:r>
-            </a:p>
-          </p:txBody>
-        </p:sp>
-        <p:pic>
-          <p:nvPicPr>
-            <p:cNvPr id="8" name="Picture 7" descr="A close up of a logo&#10;&#10;Description automatically generated">
-              <a:extLst>
-                <a:ext uri="{FF2B5EF4-FFF2-40B4-BE49-F238E27FC236}">
-                  <a16:creationId xmlns:a16="http://schemas.microsoft.com/office/drawing/2014/main" id="{71485E95-32AD-B748-AC63-39B02F75B122}"/>
-                </a:ext>
-              </a:extLst>
-            </p:cNvPr>
-            <p:cNvPicPr>
-              <a:picLocks noChangeAspect="1"/>
-            </p:cNvPicPr>
-            <p:nvPr/>
-          </p:nvPicPr>
-          <p:blipFill>
-            <a:blip r:embed="rId3"/>
-            <a:stretch>
-              <a:fillRect/>
-            </a:stretch>
-          </p:blipFill>
-          <p:spPr>
-            <a:xfrm>
-              <a:off x="6538573" y="4900186"/>
-              <a:ext cx="882896" cy="548466"/>
-            </a:xfrm>
-            <a:prstGeom prst="rect">
-              <a:avLst/>
-            </a:prstGeom>
-          </p:spPr>
-        </p:pic>
-      </p:grpSp>
-      <p:pic>
-        <p:nvPicPr>
-          <p:cNvPr id="10" name="Picture 9">
-            <a:extLst>
-              <a:ext uri="{FF2B5EF4-FFF2-40B4-BE49-F238E27FC236}">
-                <a16:creationId xmlns:a16="http://schemas.microsoft.com/office/drawing/2014/main" id="{05D49C1C-32D1-8A52-BE5B-63FF9F1BA2E8}"/>
-              </a:ext>
-            </a:extLst>
-          </p:cNvPr>
-          <p:cNvPicPr>
-            <a:picLocks noChangeAspect="1"/>
-          </p:cNvPicPr>
-          <p:nvPr/>
-        </p:nvPicPr>
-        <p:blipFill>
-          <a:blip r:embed="rId4"/>
-          <a:stretch>
-            <a:fillRect/>
-          </a:stretch>
-        </p:blipFill>
-        <p:spPr>
-          <a:xfrm>
-            <a:off x="304390" y="6123930"/>
-            <a:ext cx="2069810" cy="449736"/>
-          </a:xfrm>
-          <a:prstGeom prst="rect">
-            <a:avLst/>
-          </a:prstGeom>
-        </p:spPr>
-      </p:pic>
-      <p:pic>
-        <p:nvPicPr>
-          <p:cNvPr id="11" name="Picture 10">
-            <a:extLst>
-              <a:ext uri="{FF2B5EF4-FFF2-40B4-BE49-F238E27FC236}">
-                <a16:creationId xmlns:a16="http://schemas.microsoft.com/office/drawing/2014/main" id="{ADF7E6EE-DEE4-2C87-C47E-847F5553B0A6}"/>
-              </a:ext>
-            </a:extLst>
-          </p:cNvPr>
-          <p:cNvPicPr>
-            <a:picLocks noChangeAspect="1"/>
-          </p:cNvPicPr>
-          <p:nvPr/>
-        </p:nvPicPr>
-        <p:blipFill>
-          <a:blip r:embed="rId5"/>
-          <a:stretch>
-            <a:fillRect/>
-          </a:stretch>
-        </p:blipFill>
-        <p:spPr>
-          <a:xfrm>
-            <a:off x="10541056" y="5212903"/>
-            <a:ext cx="1078668" cy="1078668"/>
-          </a:xfrm>
-          <a:prstGeom prst="rect">
-            <a:avLst/>
-          </a:prstGeom>
-        </p:spPr>
-      </p:pic>
-    </p:spTree>
-    <p:extLst>
-      <p:ext uri="{BB962C8B-B14F-4D97-AF65-F5344CB8AC3E}">
-        <p14:creationId xmlns:p14="http://schemas.microsoft.com/office/powerpoint/2010/main" val="1735809827"/>
       </p:ext>
     </p:extLst>
   </p:cSld>

</xml_diff>